<commit_message>
Slides: nomes reais da equipe, professor e mentores no slide 1
Co-Authored-By: Claude Sonnet 5 <noreply@anthropic.com>
</commit_message>
<xml_diff>
--- a/docs/pitch/VisionEPI-pitch-v3.pptx
+++ b/docs/pitch/VisionEPI-pitch-v3.pptx
@@ -1778,8 +1778,8 @@
         </p:nvSpPr>
         <p:spPr>
           <a:xfrm>
-            <a:off x="640080" y="4160520"/>
-            <a:ext cx="7863840" cy="274320"/>
+            <a:off x="640080" y="4114800"/>
+            <a:ext cx="7863840" cy="256032"/>
           </a:xfrm>
           <a:prstGeom prst="rect">
             <a:avLst/>
@@ -1803,9 +1803,87 @@
                 <a:ea typeface="Calibri" pitchFamily="34" charset="-122"/>
                 <a:cs typeface="Calibri" pitchFamily="34" charset="-120"/>
               </a:rPr>
-              <a:t>[Nome 1]  ·  [Nome 2]  ·  [Nome 3]  ·  [Curso / turma]</a:t>
+              <a:t>Lucas Baraldi Rodrigues  ·  Lucas Zolla Assis</a:t>
             </a:r>
             <a:endParaRPr lang="en-US" sz="1200" dirty="0"/>
+          </a:p>
+        </p:txBody>
+      </p:sp>
+      <p:sp>
+        <p:nvSpPr>
+          <p:cNvPr id="8" name="Text 5"/>
+          <p:cNvSpPr txBox="1"/>
+          <p:nvPr/>
+        </p:nvSpPr>
+        <p:spPr>
+          <a:xfrm>
+            <a:off x="640080" y="4370832"/>
+            <a:ext cx="7863840" cy="256032"/>
+          </a:xfrm>
+          <a:prstGeom prst="rect">
+            <a:avLst/>
+          </a:prstGeom>
+          <a:noFill/>
+          <a:ln/>
+        </p:spPr>
+        <p:txBody>
+          <a:bodyPr wrap="square" lIns="0" tIns="0" rIns="0" bIns="0" rtlCol="0" anchor="ctr"/>
+          <a:lstStyle/>
+          <a:p>
+            <a:pPr indent="0" marL="0">
+              <a:buNone/>
+            </a:pPr>
+            <a:r>
+              <a:rPr lang="en-US" sz="1200" dirty="0">
+                <a:solidFill>
+                  <a:srgbClr val="94A3B8"/>
+                </a:solidFill>
+                <a:latin typeface="Calibri" pitchFamily="34" charset="0"/>
+                <a:ea typeface="Calibri" pitchFamily="34" charset="-122"/>
+                <a:cs typeface="Calibri" pitchFamily="34" charset="-120"/>
+              </a:rPr>
+              <a:t>Pedro Costa Belisário  ·  Vitor Pantarotto de Brito</a:t>
+            </a:r>
+            <a:endParaRPr lang="en-US" sz="1200" dirty="0"/>
+          </a:p>
+        </p:txBody>
+      </p:sp>
+      <p:sp>
+        <p:nvSpPr>
+          <p:cNvPr id="9" name="Text 6"/>
+          <p:cNvSpPr txBox="1"/>
+          <p:nvPr/>
+        </p:nvSpPr>
+        <p:spPr>
+          <a:xfrm>
+            <a:off x="640080" y="4663440"/>
+            <a:ext cx="7863840" cy="228600"/>
+          </a:xfrm>
+          <a:prstGeom prst="rect">
+            <a:avLst/>
+          </a:prstGeom>
+          <a:noFill/>
+          <a:ln/>
+        </p:spPr>
+        <p:txBody>
+          <a:bodyPr wrap="square" lIns="0" tIns="0" rIns="0" bIns="0" rtlCol="0" anchor="ctr"/>
+          <a:lstStyle/>
+          <a:p>
+            <a:pPr indent="0" marL="0">
+              <a:buNone/>
+            </a:pPr>
+            <a:r>
+              <a:rPr lang="en-US" sz="1050" dirty="0">
+                <a:solidFill>
+                  <a:srgbClr val="64748B"/>
+                </a:solidFill>
+                <a:latin typeface="Calibri" pitchFamily="34" charset="0"/>
+                <a:ea typeface="Calibri" pitchFamily="34" charset="-122"/>
+                <a:cs typeface="Calibri" pitchFamily="34" charset="-120"/>
+              </a:rPr>
+              <a:t>Prof. Fabio Henrique Pimentel  ·  Mentores: Fernando Marcolina e Wendel de Almeida Passos</a:t>
+            </a:r>
+            <a:endParaRPr lang="en-US" sz="1050" dirty="0"/>
           </a:p>
         </p:txBody>
       </p:sp>

</xml_diff>